<commit_message>
se añade la documentacion de la Tarea 6
</commit_message>
<xml_diff>
--- a/Tarea_6/Acceso_no_autorizado_MFA_Tarea_6.pptx
+++ b/Tarea_6/Acceso_no_autorizado_MFA_Tarea_6.pptx
@@ -3506,33 +3506,9 @@
           </a:blipFill>
         </p:spPr>
       </p:sp>
-      <p:sp>
-        <p:nvSpPr>
-          <p:cNvPr name="AutoShape 14" id="14"/>
-          <p:cNvSpPr/>
-          <p:nvPr/>
-        </p:nvSpPr>
-        <p:spPr>
-          <a:xfrm>
-            <a:off x="5897880" y="5143500"/>
-            <a:ext cx="6492240" cy="0"/>
-          </a:xfrm>
-          <a:prstGeom prst="line">
-            <a:avLst/>
-          </a:prstGeom>
-          <a:ln cap="flat" w="38100">
-            <a:solidFill>
-              <a:srgbClr val="000000"/>
-            </a:solidFill>
-            <a:prstDash val="solid"/>
-            <a:headEnd type="none" len="sm" w="sm"/>
-            <a:tailEnd type="none" len="sm" w="sm"/>
-          </a:ln>
-        </p:spPr>
-      </p:sp>
       <p:grpSp>
         <p:nvGrpSpPr>
-          <p:cNvPr name="Group 15" id="15"/>
+          <p:cNvPr name="Group 14" id="14"/>
           <p:cNvGrpSpPr/>
           <p:nvPr/>
         </p:nvGrpSpPr>
@@ -3546,7 +3522,7 @@
         </p:grpSpPr>
         <p:sp>
           <p:nvSpPr>
-            <p:cNvPr name="Freeform 16" id="16"/>
+            <p:cNvPr name="Freeform 15" id="15"/>
             <p:cNvSpPr/>
             <p:nvPr/>
           </p:nvSpPr>
@@ -3598,7 +3574,7 @@
         </p:sp>
         <p:sp>
           <p:nvSpPr>
-            <p:cNvPr name="TextBox 17" id="17"/>
+            <p:cNvPr name="TextBox 16" id="16"/>
             <p:cNvSpPr txBox="true"/>
             <p:nvPr/>
           </p:nvSpPr>
@@ -3626,7 +3602,7 @@
       </p:grpSp>
       <p:grpSp>
         <p:nvGrpSpPr>
-          <p:cNvPr name="Group 18" id="18"/>
+          <p:cNvPr name="Group 17" id="17"/>
           <p:cNvGrpSpPr/>
           <p:nvPr/>
         </p:nvGrpSpPr>
@@ -3640,7 +3616,7 @@
         </p:grpSpPr>
         <p:sp>
           <p:nvSpPr>
-            <p:cNvPr name="Freeform 19" id="19"/>
+            <p:cNvPr name="Freeform 18" id="18"/>
             <p:cNvSpPr/>
             <p:nvPr/>
           </p:nvSpPr>
@@ -3692,7 +3668,7 @@
         </p:sp>
         <p:sp>
           <p:nvSpPr>
-            <p:cNvPr name="TextBox 20" id="20"/>
+            <p:cNvPr name="TextBox 19" id="19"/>
             <p:cNvSpPr txBox="true"/>
             <p:nvPr/>
           </p:nvSpPr>
@@ -3720,7 +3696,7 @@
       </p:grpSp>
       <p:grpSp>
         <p:nvGrpSpPr>
-          <p:cNvPr name="Group 21" id="21"/>
+          <p:cNvPr name="Group 20" id="20"/>
           <p:cNvGrpSpPr/>
           <p:nvPr/>
         </p:nvGrpSpPr>
@@ -3734,7 +3710,7 @@
         </p:grpSpPr>
         <p:sp>
           <p:nvSpPr>
-            <p:cNvPr name="Freeform 22" id="22"/>
+            <p:cNvPr name="Freeform 21" id="21"/>
             <p:cNvSpPr/>
             <p:nvPr/>
           </p:nvSpPr>
@@ -3786,7 +3762,7 @@
         </p:sp>
         <p:sp>
           <p:nvSpPr>
-            <p:cNvPr name="TextBox 23" id="23"/>
+            <p:cNvPr name="TextBox 22" id="22"/>
             <p:cNvSpPr txBox="true"/>
             <p:nvPr/>
           </p:nvSpPr>

</xml_diff>